<commit_message>
Add official MCP architecture diagram slide to MCP-핵심정리 deck
Co-Authored-By: Claude Fable 5 <noreply@anthropic.com>
</commit_message>
<xml_diff>
--- a/MCP/MCP-핵심정리.pptx
+++ b/MCP/MCP-핵심정리.pptx
@@ -24,9 +24,10 @@
     <p:sldId id="272" r:id="rId18"/>
     <p:sldId id="273" r:id="rId19"/>
     <p:sldId id="274" r:id="rId20"/>
+    <p:sldId id="275" r:id="rId21"/>
   </p:sldIdLst>
   <p:notesMasterIdLst>
-    <p:notesMasterId r:id="rId21"/>
+    <p:notesMasterId r:id="rId22"/>
   </p:notesMasterIdLst>
   <p:sldSz cx="12192000" cy="6858000"/>
   <p:notesSz cx="6858000" cy="12192000"/>
@@ -1512,6 +1513,94 @@
             <a:fld id="{F7021451-1387-4CA6-816F-3879F97B5CBC}" type="slidenum">
               <a:rPr lang="en-US"/>
               <a:t>2</a:t>
+            </a:fld>
+            <a:endParaRPr lang="en-US"/>
+          </a:p>
+        </p:txBody>
+      </p:sp>
+    </p:spTree>
+    <p:extLst>
+      <p:ext uri="{BB962C8B-B14F-4D97-AF65-F5344CB8AC3E}">
+        <p14:creationId xmlns:p14="http://schemas.microsoft.com/office/powerpoint/2010/main" val="1024086991"/>
+      </p:ext>
+    </p:extLst>
+  </p:cSld>
+  <p:clrMapOvr>
+    <a:masterClrMapping/>
+  </p:clrMapOvr>
+</p:notes>
+</file>
+
+<file path=ppt/notesSlides/notesSlide20.xml><?xml version="1.0" encoding="utf-8"?>
+<p:notes xmlns:a="http://schemas.openxmlformats.org/drawingml/2006/main" xmlns:r="http://schemas.openxmlformats.org/officeDocument/2006/relationships" xmlns:p="http://schemas.openxmlformats.org/presentationml/2006/main">
+  <p:cSld>
+    <p:spTree>
+      <p:nvGrpSpPr>
+        <p:cNvPr id="1" name=""/>
+        <p:cNvGrpSpPr/>
+        <p:nvPr/>
+      </p:nvGrpSpPr>
+      <p:grpSpPr>
+        <a:xfrm>
+          <a:off x="0" y="0"/>
+          <a:ext cx="0" cy="0"/>
+          <a:chOff x="0" y="0"/>
+          <a:chExt cx="0" cy="0"/>
+        </a:xfrm>
+      </p:grpSpPr>
+      <p:sp>
+        <p:nvSpPr>
+          <p:cNvPr id="2" name="Slide Image Placeholder 1"/>
+          <p:cNvSpPr>
+            <a:spLocks noGrp="1" noRot="1" noChangeAspect="1"/>
+          </p:cNvSpPr>
+          <p:nvPr>
+            <p:ph type="sldImg"/>
+          </p:nvPr>
+        </p:nvSpPr>
+        <p:spPr/>
+      </p:sp>
+      <p:sp>
+        <p:nvSpPr>
+          <p:cNvPr id="3" name="Notes Placeholder 2"/>
+          <p:cNvSpPr>
+            <a:spLocks noGrp="1"/>
+          </p:cNvSpPr>
+          <p:nvPr>
+            <p:ph type="body" idx="1"/>
+          </p:nvPr>
+        </p:nvSpPr>
+        <p:spPr/>
+        <p:txBody>
+          <a:bodyPr/>
+          <a:lstStyle/>
+          <a:p>
+            <a:r>
+              <a:rPr lang="en-US" dirty="0"/>
+              <a:t/>
+            </a:r>
+            <a:endParaRPr lang="en-US" dirty="0"/>
+          </a:p>
+        </p:txBody>
+      </p:sp>
+      <p:sp>
+        <p:nvSpPr>
+          <p:cNvPr id="4" name="Slide Number Placeholder 3"/>
+          <p:cNvSpPr>
+            <a:spLocks noGrp="1"/>
+          </p:cNvSpPr>
+          <p:nvPr>
+            <p:ph type="sldNum" sz="quarter" idx="10"/>
+          </p:nvPr>
+        </p:nvSpPr>
+        <p:spPr/>
+        <p:txBody>
+          <a:bodyPr/>
+          <a:lstStyle/>
+          <a:p>
+            <a:fld id="{F7021451-1387-4CA6-816F-3879F97B5CBC}" type="slidenum">
+              <a:rPr lang="en-US"/>
+              <a:t>20</a:t>
             </a:fld>
             <a:endParaRPr lang="en-US"/>
           </a:p>
@@ -2698,7 +2787,7 @@
                 <a:ea typeface="Malgun Gothic" pitchFamily="34" charset="-122"/>
                 <a:cs typeface="Malgun Gothic" pitchFamily="34" charset="-120"/>
               </a:rPr>
-              <a:t>② MCP CLIENT</a:t>
+              <a:t>① MCP HOST</a:t>
             </a:r>
             <a:endParaRPr lang="en-US" sz="1200" dirty="0"/>
           </a:p>
@@ -2737,7 +2826,7 @@
                 <a:ea typeface="Malgun Gothic" pitchFamily="34" charset="-122"/>
                 <a:cs typeface="Malgun Gothic" pitchFamily="34" charset="-120"/>
               </a:rPr>
-              <a:t>MCP Client — 중개자</a:t>
+              <a:t>MCP Host — 지휘관</a:t>
             </a:r>
             <a:endParaRPr lang="en-US" sz="2800" dirty="0"/>
           </a:p>
@@ -2769,7 +2858,7 @@
                 <a:spcPct val="105000"/>
               </a:lnSpc>
               <a:spcAft>
-                <a:spcPts val="1300"/>
+                <a:spcPts val="1600"/>
               </a:spcAft>
               <a:buSzPct val="100000"/>
               <a:buChar char="–"/>
@@ -2783,7 +2872,7 @@
                 <a:ea typeface="Malgun Gothic" pitchFamily="34" charset="-122"/>
                 <a:cs typeface="Malgun Gothic" pitchFamily="34" charset="-120"/>
               </a:rPr>
-              <a:t>Host와 Server 사이를 잇는 커넥터.</a:t>
+              <a:t>모든 것을 결정하는 앱 본체. LLM을 품고 있다.</a:t>
             </a:r>
             <a:endParaRPr lang="en-US" sz="1600" dirty="0"/>
           </a:p>
@@ -2793,7 +2882,7 @@
                 <a:spcPct val="105000"/>
               </a:lnSpc>
               <a:spcAft>
-                <a:spcPts val="1300"/>
+                <a:spcPts val="1600"/>
               </a:spcAft>
               <a:buSzPct val="100000"/>
               <a:buChar char="–"/>
@@ -2807,7 +2896,7 @@
                 <a:ea typeface="Malgun Gothic" pitchFamily="34" charset="-122"/>
                 <a:cs typeface="Malgun Gothic" pitchFamily="34" charset="-120"/>
               </a:rPr>
-              <a:t>각 MCP 서버와 1:1 연결을 유지한다.</a:t>
+              <a:t>사용자 요청 이해·분석 → 필요한 도구 결정 → 작업 계획 수립 → 최종 응답 생성.</a:t>
             </a:r>
             <a:endParaRPr lang="en-US" sz="1600" dirty="0"/>
           </a:p>
@@ -2817,7 +2906,7 @@
                 <a:spcPct val="105000"/>
               </a:lnSpc>
               <a:spcAft>
-                <a:spcPts val="1300"/>
+                <a:spcPts val="1600"/>
               </a:spcAft>
               <a:buSzPct val="100000"/>
               <a:buChar char="–"/>
@@ -2831,31 +2920,7 @@
                 <a:ea typeface="Malgun Gothic" pitchFamily="34" charset="-122"/>
                 <a:cs typeface="Malgun Gothic" pitchFamily="34" charset="-120"/>
               </a:rPr>
-              <a:t>Host 애플리케이션 안에서 실행 — 별도 앱이 아니라 Host의 부품.</a:t>
-            </a:r>
-            <a:endParaRPr lang="en-US" sz="1600" dirty="0"/>
-          </a:p>
-          <a:p>
-            <a:pPr marL="203200" indent="-203200">
-              <a:lnSpc>
-                <a:spcPct val="105000"/>
-              </a:lnSpc>
-              <a:spcAft>
-                <a:spcPts val="1300"/>
-              </a:spcAft>
-              <a:buSzPct val="100000"/>
-              <a:buChar char="–"/>
-            </a:pPr>
-            <a:r>
-              <a:rPr lang="en-US" sz="1600" dirty="0">
-                <a:solidFill>
-                  <a:srgbClr val="3E4C59"/>
-                </a:solidFill>
-                <a:latin typeface="Malgun Gothic" pitchFamily="34" charset="0"/>
-                <a:ea typeface="Malgun Gothic" pitchFamily="34" charset="-122"/>
-                <a:cs typeface="Malgun Gothic" pitchFamily="34" charset="-120"/>
-              </a:rPr>
-              <a:t>도구를 직접 실행하지 않고 통신만 중개한다.</a:t>
+              <a:t>예: Claude Desktop, Cursor.</a:t>
             </a:r>
             <a:endParaRPr lang="en-US" sz="1600" dirty="0"/>
           </a:p>
@@ -2926,7 +2991,7 @@
                 <a:ea typeface="Malgun Gothic" pitchFamily="34" charset="-122"/>
                 <a:cs typeface="Malgun Gothic" pitchFamily="34" charset="-120"/>
               </a:rPr>
-              <a:t>③ MCP SERVER</a:t>
+              <a:t>② MCP CLIENT</a:t>
             </a:r>
             <a:endParaRPr lang="en-US" sz="1200" dirty="0"/>
           </a:p>
@@ -2965,6 +3030,234 @@
                 <a:ea typeface="Malgun Gothic" pitchFamily="34" charset="-122"/>
                 <a:cs typeface="Malgun Gothic" pitchFamily="34" charset="-120"/>
               </a:rPr>
+              <a:t>MCP Client — 중개자</a:t>
+            </a:r>
+            <a:endParaRPr lang="en-US" sz="2800" dirty="0"/>
+          </a:p>
+        </p:txBody>
+      </p:sp>
+      <p:sp>
+        <p:nvSpPr>
+          <p:cNvPr id="4" name="Text 2"/>
+          <p:cNvSpPr/>
+          <p:nvPr/>
+        </p:nvSpPr>
+        <p:spPr>
+          <a:xfrm>
+            <a:off x="822960" y="1920240"/>
+            <a:ext cx="10698480" cy="3200400"/>
+          </a:xfrm>
+          <a:prstGeom prst="rect">
+            <a:avLst/>
+          </a:prstGeom>
+          <a:noFill/>
+          <a:ln/>
+        </p:spPr>
+        <p:txBody>
+          <a:bodyPr wrap="square" lIns="0" tIns="0" rIns="0" bIns="0" rtlCol="0" anchor="ctr"/>
+          <a:lstStyle/>
+          <a:p>
+            <a:pPr marL="203200" indent="-203200">
+              <a:lnSpc>
+                <a:spcPct val="105000"/>
+              </a:lnSpc>
+              <a:spcAft>
+                <a:spcPts val="1300"/>
+              </a:spcAft>
+              <a:buSzPct val="100000"/>
+              <a:buChar char="–"/>
+            </a:pPr>
+            <a:r>
+              <a:rPr lang="en-US" sz="1600" dirty="0">
+                <a:solidFill>
+                  <a:srgbClr val="3E4C59"/>
+                </a:solidFill>
+                <a:latin typeface="Malgun Gothic" pitchFamily="34" charset="0"/>
+                <a:ea typeface="Malgun Gothic" pitchFamily="34" charset="-122"/>
+                <a:cs typeface="Malgun Gothic" pitchFamily="34" charset="-120"/>
+              </a:rPr>
+              <a:t>Host와 Server 사이를 잇는 커넥터.</a:t>
+            </a:r>
+            <a:endParaRPr lang="en-US" sz="1600" dirty="0"/>
+          </a:p>
+          <a:p>
+            <a:pPr marL="203200" indent="-203200">
+              <a:lnSpc>
+                <a:spcPct val="105000"/>
+              </a:lnSpc>
+              <a:spcAft>
+                <a:spcPts val="1300"/>
+              </a:spcAft>
+              <a:buSzPct val="100000"/>
+              <a:buChar char="–"/>
+            </a:pPr>
+            <a:r>
+              <a:rPr lang="en-US" sz="1600" dirty="0">
+                <a:solidFill>
+                  <a:srgbClr val="3E4C59"/>
+                </a:solidFill>
+                <a:latin typeface="Malgun Gothic" pitchFamily="34" charset="0"/>
+                <a:ea typeface="Malgun Gothic" pitchFamily="34" charset="-122"/>
+                <a:cs typeface="Malgun Gothic" pitchFamily="34" charset="-120"/>
+              </a:rPr>
+              <a:t>각 MCP 서버와 1:1 연결을 유지한다.</a:t>
+            </a:r>
+            <a:endParaRPr lang="en-US" sz="1600" dirty="0"/>
+          </a:p>
+          <a:p>
+            <a:pPr marL="203200" indent="-203200">
+              <a:lnSpc>
+                <a:spcPct val="105000"/>
+              </a:lnSpc>
+              <a:spcAft>
+                <a:spcPts val="1300"/>
+              </a:spcAft>
+              <a:buSzPct val="100000"/>
+              <a:buChar char="–"/>
+            </a:pPr>
+            <a:r>
+              <a:rPr lang="en-US" sz="1600" dirty="0">
+                <a:solidFill>
+                  <a:srgbClr val="3E4C59"/>
+                </a:solidFill>
+                <a:latin typeface="Malgun Gothic" pitchFamily="34" charset="0"/>
+                <a:ea typeface="Malgun Gothic" pitchFamily="34" charset="-122"/>
+                <a:cs typeface="Malgun Gothic" pitchFamily="34" charset="-120"/>
+              </a:rPr>
+              <a:t>Host 애플리케이션 안에서 실행 — 별도 앱이 아니라 Host의 부품.</a:t>
+            </a:r>
+            <a:endParaRPr lang="en-US" sz="1600" dirty="0"/>
+          </a:p>
+          <a:p>
+            <a:pPr marL="203200" indent="-203200">
+              <a:lnSpc>
+                <a:spcPct val="105000"/>
+              </a:lnSpc>
+              <a:spcAft>
+                <a:spcPts val="1300"/>
+              </a:spcAft>
+              <a:buSzPct val="100000"/>
+              <a:buChar char="–"/>
+            </a:pPr>
+            <a:r>
+              <a:rPr lang="en-US" sz="1600" dirty="0">
+                <a:solidFill>
+                  <a:srgbClr val="3E4C59"/>
+                </a:solidFill>
+                <a:latin typeface="Malgun Gothic" pitchFamily="34" charset="0"/>
+                <a:ea typeface="Malgun Gothic" pitchFamily="34" charset="-122"/>
+                <a:cs typeface="Malgun Gothic" pitchFamily="34" charset="-120"/>
+              </a:rPr>
+              <a:t>도구를 직접 실행하지 않고 통신만 중개한다.</a:t>
+            </a:r>
+            <a:endParaRPr lang="en-US" sz="1600" dirty="0"/>
+          </a:p>
+        </p:txBody>
+      </p:sp>
+    </p:spTree>
+  </p:cSld>
+  <p:clrMapOvr>
+    <a:masterClrMapping/>
+  </p:clrMapOvr>
+</p:sld>
+</file>
+
+<file path=ppt/slides/slide12.xml><?xml version="1.0" encoding="utf-8"?>
+<p:sld xmlns:a="http://schemas.openxmlformats.org/drawingml/2006/main" xmlns:r="http://schemas.openxmlformats.org/officeDocument/2006/relationships" xmlns:p="http://schemas.openxmlformats.org/presentationml/2006/main">
+  <p:cSld name="Slide 12">
+    <p:bg>
+      <p:bgPr>
+        <a:solidFill>
+          <a:srgbClr val="FFFFFF"/>
+        </a:solidFill>
+      </p:bgPr>
+    </p:bg>
+    <p:spTree>
+      <p:nvGrpSpPr>
+        <p:cNvPr id="1" name=""/>
+        <p:cNvGrpSpPr/>
+        <p:nvPr/>
+      </p:nvGrpSpPr>
+      <p:grpSpPr>
+        <a:xfrm>
+          <a:off x="0" y="0"/>
+          <a:ext cx="0" cy="0"/>
+          <a:chOff x="0" y="0"/>
+          <a:chExt cx="0" cy="0"/>
+        </a:xfrm>
+      </p:grpSpPr>
+      <p:sp>
+        <p:nvSpPr>
+          <p:cNvPr id="2" name="Text 0"/>
+          <p:cNvSpPr/>
+          <p:nvPr/>
+        </p:nvSpPr>
+        <p:spPr>
+          <a:xfrm>
+            <a:off x="640080" y="502920"/>
+            <a:ext cx="10972800" cy="320040"/>
+          </a:xfrm>
+          <a:prstGeom prst="rect">
+            <a:avLst/>
+          </a:prstGeom>
+          <a:noFill/>
+          <a:ln/>
+        </p:spPr>
+        <p:txBody>
+          <a:bodyPr wrap="square" lIns="0" tIns="0" rIns="0" bIns="0" rtlCol="0" anchor="ctr"/>
+          <a:lstStyle/>
+          <a:p>
+            <a:pPr indent="0" marL="0">
+              <a:buNone/>
+            </a:pPr>
+            <a:r>
+              <a:rPr lang="en-US" sz="1200" b="1" spc="200" kern="0" dirty="0">
+                <a:solidFill>
+                  <a:srgbClr val="0B7285"/>
+                </a:solidFill>
+                <a:latin typeface="Malgun Gothic" pitchFamily="34" charset="0"/>
+                <a:ea typeface="Malgun Gothic" pitchFamily="34" charset="-122"/>
+                <a:cs typeface="Malgun Gothic" pitchFamily="34" charset="-120"/>
+              </a:rPr>
+              <a:t>③ MCP SERVER</a:t>
+            </a:r>
+            <a:endParaRPr lang="en-US" sz="1200" dirty="0"/>
+          </a:p>
+        </p:txBody>
+      </p:sp>
+      <p:sp>
+        <p:nvSpPr>
+          <p:cNvPr id="3" name="Text 1"/>
+          <p:cNvSpPr/>
+          <p:nvPr/>
+        </p:nvSpPr>
+        <p:spPr>
+          <a:xfrm>
+            <a:off x="640080" y="841248"/>
+            <a:ext cx="10972800" cy="640080"/>
+          </a:xfrm>
+          <a:prstGeom prst="rect">
+            <a:avLst/>
+          </a:prstGeom>
+          <a:noFill/>
+          <a:ln/>
+        </p:spPr>
+        <p:txBody>
+          <a:bodyPr wrap="square" lIns="0" tIns="0" rIns="0" bIns="0" rtlCol="0" anchor="ctr"/>
+          <a:lstStyle/>
+          <a:p>
+            <a:pPr indent="0" marL="0">
+              <a:buNone/>
+            </a:pPr>
+            <a:r>
+              <a:rPr lang="en-US" sz="2800" b="1" dirty="0">
+                <a:solidFill>
+                  <a:srgbClr val="1F2933"/>
+                </a:solidFill>
+                <a:latin typeface="Malgun Gothic" pitchFamily="34" charset="0"/>
+                <a:ea typeface="Malgun Gothic" pitchFamily="34" charset="-122"/>
+                <a:cs typeface="Malgun Gothic" pitchFamily="34" charset="-120"/>
+              </a:rPr>
               <a:t>MCP Server — 실제 도구 제공</a:t>
             </a:r>
             <a:endParaRPr lang="en-US" sz="2800" dirty="0"/>
@@ -3051,7 +3344,7 @@
       </p:sp>
       <p:graphicFrame>
         <p:nvGraphicFramePr>
-          <p:cNvPr id="12" name="Table 0"/>
+          <p:cNvPr id="13" name="Table 0"/>
           <p:cNvGraphicFramePr>
             <a:graphicFrameLocks noGrp="1"/>
           </p:cNvGraphicFramePr>
@@ -3688,9 +3981,9 @@
 </p:sld>
 </file>
 
-<file path=ppt/slides/slide12.xml><?xml version="1.0" encoding="utf-8"?>
+<file path=ppt/slides/slide13.xml><?xml version="1.0" encoding="utf-8"?>
 <p:sld xmlns:a="http://schemas.openxmlformats.org/drawingml/2006/main" xmlns:r="http://schemas.openxmlformats.org/officeDocument/2006/relationships" xmlns:p="http://schemas.openxmlformats.org/presentationml/2006/main">
-  <p:cSld name="Slide 12">
+  <p:cSld name="Slide 13">
     <p:bg>
       <p:bgPr>
         <a:solidFill>
@@ -3792,7 +4085,7 @@
       </p:sp>
       <p:graphicFrame>
         <p:nvGraphicFramePr>
-          <p:cNvPr id="13" name="Table 0"/>
+          <p:cNvPr id="14" name="Table 0"/>
           <p:cNvGraphicFramePr>
             <a:graphicFrameLocks noGrp="1"/>
           </p:cNvGraphicFramePr>
@@ -4203,9 +4496,9 @@
 </p:sld>
 </file>
 
-<file path=ppt/slides/slide13.xml><?xml version="1.0" encoding="utf-8"?>
+<file path=ppt/slides/slide14.xml><?xml version="1.0" encoding="utf-8"?>
 <p:sld xmlns:a="http://schemas.openxmlformats.org/drawingml/2006/main" xmlns:r="http://schemas.openxmlformats.org/officeDocument/2006/relationships" xmlns:p="http://schemas.openxmlformats.org/presentationml/2006/main">
-  <p:cSld name="Slide 13">
+  <p:cSld name="Slide 14">
     <p:bg>
       <p:bgPr>
         <a:solidFill>
@@ -4407,9 +4700,9 @@
 </p:sld>
 </file>
 
-<file path=ppt/slides/slide14.xml><?xml version="1.0" encoding="utf-8"?>
+<file path=ppt/slides/slide15.xml><?xml version="1.0" encoding="utf-8"?>
 <p:sld xmlns:a="http://schemas.openxmlformats.org/drawingml/2006/main" xmlns:r="http://schemas.openxmlformats.org/officeDocument/2006/relationships" xmlns:p="http://schemas.openxmlformats.org/presentationml/2006/main">
-  <p:cSld name="Slide 14">
+  <p:cSld name="Slide 15">
     <p:bg>
       <p:bgPr>
         <a:solidFill>
@@ -4511,7 +4804,7 @@
       </p:sp>
       <p:graphicFrame>
         <p:nvGraphicFramePr>
-          <p:cNvPr id="15" name="Table 0"/>
+          <p:cNvPr id="16" name="Table 0"/>
           <p:cNvGraphicFramePr>
             <a:graphicFrameLocks noGrp="1"/>
           </p:cNvGraphicFramePr>
@@ -4940,9 +5233,9 @@
 </p:sld>
 </file>
 
-<file path=ppt/slides/slide15.xml><?xml version="1.0" encoding="utf-8"?>
+<file path=ppt/slides/slide16.xml><?xml version="1.0" encoding="utf-8"?>
 <p:sld xmlns:a="http://schemas.openxmlformats.org/drawingml/2006/main" xmlns:r="http://schemas.openxmlformats.org/officeDocument/2006/relationships" xmlns:p="http://schemas.openxmlformats.org/presentationml/2006/main">
-  <p:cSld name="Slide 15">
+  <p:cSld name="Slide 16">
     <p:bg>
       <p:bgPr>
         <a:solidFill>
@@ -5044,7 +5337,7 @@
       </p:sp>
       <p:graphicFrame>
         <p:nvGraphicFramePr>
-          <p:cNvPr id="16" name="Table 0"/>
+          <p:cNvPr id="17" name="Table 0"/>
           <p:cNvGraphicFramePr>
             <a:graphicFrameLocks noGrp="1"/>
           </p:cNvGraphicFramePr>
@@ -5392,9 +5685,9 @@
 </p:sld>
 </file>
 
-<file path=ppt/slides/slide16.xml><?xml version="1.0" encoding="utf-8"?>
+<file path=ppt/slides/slide17.xml><?xml version="1.0" encoding="utf-8"?>
 <p:sld xmlns:a="http://schemas.openxmlformats.org/drawingml/2006/main" xmlns:r="http://schemas.openxmlformats.org/officeDocument/2006/relationships" xmlns:p="http://schemas.openxmlformats.org/presentationml/2006/main">
-  <p:cSld name="Slide 16">
+  <p:cSld name="Slide 17">
     <p:bg>
       <p:bgPr>
         <a:solidFill>
@@ -5609,249 +5902,6 @@
               <a:t>운영 시스템 침해 — 백도어 설치·리소스 오용으로 시스템 전체 위협.</a:t>
             </a:r>
             <a:endParaRPr lang="en-US" sz="1600" dirty="0"/>
-          </a:p>
-        </p:txBody>
-      </p:sp>
-    </p:spTree>
-  </p:cSld>
-  <p:clrMapOvr>
-    <a:masterClrMapping/>
-  </p:clrMapOvr>
-</p:sld>
-</file>
-
-<file path=ppt/slides/slide17.xml><?xml version="1.0" encoding="utf-8"?>
-<p:sld xmlns:a="http://schemas.openxmlformats.org/drawingml/2006/main" xmlns:r="http://schemas.openxmlformats.org/officeDocument/2006/relationships" xmlns:p="http://schemas.openxmlformats.org/presentationml/2006/main">
-  <p:cSld name="Slide 17">
-    <p:bg>
-      <p:bgPr>
-        <a:solidFill>
-          <a:srgbClr val="FFFFFF"/>
-        </a:solidFill>
-      </p:bgPr>
-    </p:bg>
-    <p:spTree>
-      <p:nvGrpSpPr>
-        <p:cNvPr id="1" name=""/>
-        <p:cNvGrpSpPr/>
-        <p:nvPr/>
-      </p:nvGrpSpPr>
-      <p:grpSpPr>
-        <a:xfrm>
-          <a:off x="0" y="0"/>
-          <a:ext cx="0" cy="0"/>
-          <a:chOff x="0" y="0"/>
-          <a:chExt cx="0" cy="0"/>
-        </a:xfrm>
-      </p:grpSpPr>
-      <p:sp>
-        <p:nvSpPr>
-          <p:cNvPr id="2" name="Text 0"/>
-          <p:cNvSpPr/>
-          <p:nvPr/>
-        </p:nvSpPr>
-        <p:spPr>
-          <a:xfrm>
-            <a:off x="640080" y="502920"/>
-            <a:ext cx="10972800" cy="320040"/>
-          </a:xfrm>
-          <a:prstGeom prst="rect">
-            <a:avLst/>
-          </a:prstGeom>
-          <a:noFill/>
-          <a:ln/>
-        </p:spPr>
-        <p:txBody>
-          <a:bodyPr wrap="square" lIns="0" tIns="0" rIns="0" bIns="0" rtlCol="0" anchor="ctr"/>
-          <a:lstStyle/>
-          <a:p>
-            <a:pPr indent="0" marL="0">
-              <a:buNone/>
-            </a:pPr>
-            <a:r>
-              <a:rPr lang="en-US" sz="1200" b="1" spc="200" kern="0" dirty="0">
-                <a:solidFill>
-                  <a:srgbClr val="0B7285"/>
-                </a:solidFill>
-                <a:latin typeface="Malgun Gothic" pitchFamily="34" charset="0"/>
-                <a:ea typeface="Malgun Gothic" pitchFamily="34" charset="-122"/>
-                <a:cs typeface="Malgun Gothic" pitchFamily="34" charset="-120"/>
-              </a:rPr>
-              <a:t>인증 전략</a:t>
-            </a:r>
-            <a:endParaRPr lang="en-US" sz="1200" dirty="0"/>
-          </a:p>
-        </p:txBody>
-      </p:sp>
-      <p:sp>
-        <p:nvSpPr>
-          <p:cNvPr id="3" name="Text 1"/>
-          <p:cNvSpPr/>
-          <p:nvPr/>
-        </p:nvSpPr>
-        <p:spPr>
-          <a:xfrm>
-            <a:off x="640080" y="841248"/>
-            <a:ext cx="10972800" cy="640080"/>
-          </a:xfrm>
-          <a:prstGeom prst="rect">
-            <a:avLst/>
-          </a:prstGeom>
-          <a:noFill/>
-          <a:ln/>
-        </p:spPr>
-        <p:txBody>
-          <a:bodyPr wrap="square" lIns="0" tIns="0" rIns="0" bIns="0" rtlCol="0" anchor="ctr"/>
-          <a:lstStyle/>
-          <a:p>
-            <a:pPr indent="0" marL="0">
-              <a:buNone/>
-            </a:pPr>
-            <a:r>
-              <a:rPr lang="en-US" sz="2800" b="1" dirty="0">
-                <a:solidFill>
-                  <a:srgbClr val="1F2933"/>
-                </a:solidFill>
-                <a:latin typeface="Malgun Gothic" pitchFamily="34" charset="0"/>
-                <a:ea typeface="Malgun Gothic" pitchFamily="34" charset="-122"/>
-                <a:cs typeface="Malgun Gothic" pitchFamily="34" charset="-120"/>
-              </a:rPr>
-              <a:t>키·토큰 관리</a:t>
-            </a:r>
-            <a:endParaRPr lang="en-US" sz="2800" dirty="0"/>
-          </a:p>
-        </p:txBody>
-      </p:sp>
-      <p:sp>
-        <p:nvSpPr>
-          <p:cNvPr id="4" name="Text 2"/>
-          <p:cNvSpPr/>
-          <p:nvPr/>
-        </p:nvSpPr>
-        <p:spPr>
-          <a:xfrm>
-            <a:off x="822960" y="1920240"/>
-            <a:ext cx="10698480" cy="3200400"/>
-          </a:xfrm>
-          <a:prstGeom prst="rect">
-            <a:avLst/>
-          </a:prstGeom>
-          <a:noFill/>
-          <a:ln/>
-        </p:spPr>
-        <p:txBody>
-          <a:bodyPr wrap="square" lIns="0" tIns="0" rIns="0" bIns="0" rtlCol="0" anchor="ctr"/>
-          <a:lstStyle/>
-          <a:p>
-            <a:pPr marL="203200" indent="-203200">
-              <a:lnSpc>
-                <a:spcPct val="105000"/>
-              </a:lnSpc>
-              <a:spcAft>
-                <a:spcPts val="1500"/>
-              </a:spcAft>
-              <a:buSzPct val="100000"/>
-              <a:buChar char="–"/>
-            </a:pPr>
-            <a:r>
-              <a:rPr lang="en-US" sz="1600" dirty="0">
-                <a:solidFill>
-                  <a:srgbClr val="3E4C59"/>
-                </a:solidFill>
-                <a:latin typeface="Malgun Gothic" pitchFamily="34" charset="0"/>
-                <a:ea typeface="Malgun Gothic" pitchFamily="34" charset="-122"/>
-                <a:cs typeface="Malgun Gothic" pitchFamily="34" charset="-120"/>
-              </a:rPr>
-              <a:t>API 키·비밀키는 코드에 직접 쓰지 않고 .env 파일에 분리한다.</a:t>
-            </a:r>
-            <a:endParaRPr lang="en-US" sz="1600" dirty="0"/>
-          </a:p>
-          <a:p>
-            <a:pPr marL="203200" indent="-203200">
-              <a:lnSpc>
-                <a:spcPct val="105000"/>
-              </a:lnSpc>
-              <a:spcAft>
-                <a:spcPts val="1500"/>
-              </a:spcAft>
-              <a:buSzPct val="100000"/>
-              <a:buChar char="–"/>
-            </a:pPr>
-            <a:r>
-              <a:rPr lang="en-US" sz="1600" dirty="0">
-                <a:solidFill>
-                  <a:srgbClr val="3E4C59"/>
-                </a:solidFill>
-                <a:latin typeface="Malgun Gothic" pitchFamily="34" charset="0"/>
-                <a:ea typeface="Malgun Gothic" pitchFamily="34" charset="-122"/>
-                <a:cs typeface="Malgun Gothic" pitchFamily="34" charset="-120"/>
-              </a:rPr>
-              <a:t>.env는 .gitignore에 넣어 Git 등 버전 관리에 올라가지 않게 한다.</a:t>
-            </a:r>
-            <a:endParaRPr lang="en-US" sz="1600" dirty="0"/>
-          </a:p>
-          <a:p>
-            <a:pPr marL="203200" indent="-203200">
-              <a:lnSpc>
-                <a:spcPct val="105000"/>
-              </a:lnSpc>
-              <a:spcAft>
-                <a:spcPts val="1500"/>
-              </a:spcAft>
-              <a:buSzPct val="100000"/>
-              <a:buChar char="–"/>
-            </a:pPr>
-            <a:r>
-              <a:rPr lang="en-US" sz="1600" dirty="0">
-                <a:solidFill>
-                  <a:srgbClr val="3E4C59"/>
-                </a:solidFill>
-                <a:latin typeface="Malgun Gothic" pitchFamily="34" charset="0"/>
-                <a:ea typeface="Malgun Gothic" pitchFamily="34" charset="-122"/>
-                <a:cs typeface="Malgun Gothic" pitchFamily="34" charset="-120"/>
-              </a:rPr>
-              <a:t>환경 변수 로딩 실패 시 안전한 기본값 제공 또는 예외 처리로 서비스 중단을 막는다.</a:t>
-            </a:r>
-            <a:endParaRPr lang="en-US" sz="1600" dirty="0"/>
-          </a:p>
-        </p:txBody>
-      </p:sp>
-      <p:sp>
-        <p:nvSpPr>
-          <p:cNvPr id="5" name="Text 3"/>
-          <p:cNvSpPr/>
-          <p:nvPr/>
-        </p:nvSpPr>
-        <p:spPr>
-          <a:xfrm>
-            <a:off x="822960" y="4572000"/>
-            <a:ext cx="10698480" cy="457200"/>
-          </a:xfrm>
-          <a:prstGeom prst="rect">
-            <a:avLst/>
-          </a:prstGeom>
-          <a:noFill/>
-          <a:ln/>
-        </p:spPr>
-        <p:txBody>
-          <a:bodyPr wrap="square" lIns="0" tIns="0" rIns="0" bIns="0" rtlCol="0" anchor="ctr"/>
-          <a:lstStyle/>
-          <a:p>
-            <a:pPr indent="0" marL="0">
-              <a:buNone/>
-            </a:pPr>
-            <a:r>
-              <a:rPr lang="en-US" sz="1500" b="1" dirty="0">
-                <a:solidFill>
-                  <a:srgbClr val="0B7285"/>
-                </a:solidFill>
-                <a:latin typeface="Malgun Gothic" pitchFamily="34" charset="0"/>
-                <a:ea typeface="Malgun Gothic" pitchFamily="34" charset="-122"/>
-                <a:cs typeface="Malgun Gothic" pitchFamily="34" charset="-120"/>
-              </a:rPr>
-              <a:t>★ 우리 실습에서도 cli_project의 .env를 .gitignore로 제외했다.</a:t>
-            </a:r>
-            <a:endParaRPr lang="en-US" sz="1500" dirty="0"/>
           </a:p>
         </p:txBody>
       </p:sp>
@@ -5920,7 +5970,7 @@
                 <a:ea typeface="Malgun Gothic" pitchFamily="34" charset="-122"/>
                 <a:cs typeface="Malgun Gothic" pitchFamily="34" charset="-120"/>
               </a:rPr>
-              <a:t>권한 관리 (AUTHORIZATION)</a:t>
+              <a:t>인증 전략</a:t>
             </a:r>
             <a:endParaRPr lang="en-US" sz="1200" dirty="0"/>
           </a:p>
@@ -5959,7 +6009,7 @@
                 <a:ea typeface="Malgun Gothic" pitchFamily="34" charset="-122"/>
                 <a:cs typeface="Malgun Gothic" pitchFamily="34" charset="-120"/>
               </a:rPr>
-              <a:t>최소 권한 원칙</a:t>
+              <a:t>키·토큰 관리</a:t>
             </a:r>
             <a:endParaRPr lang="en-US" sz="2800" dirty="0"/>
           </a:p>
@@ -5991,13 +6041,13 @@
                 <a:spcPct val="105000"/>
               </a:lnSpc>
               <a:spcAft>
-                <a:spcPts val="1200"/>
+                <a:spcPts val="1500"/>
               </a:spcAft>
               <a:buSzPct val="100000"/>
               <a:buChar char="–"/>
             </a:pPr>
             <a:r>
-              <a:rPr lang="en-US" sz="1550" dirty="0">
+              <a:rPr lang="en-US" sz="1600" dirty="0">
                 <a:solidFill>
                   <a:srgbClr val="3E4C59"/>
                 </a:solidFill>
@@ -6005,9 +6055,9 @@
                 <a:ea typeface="Malgun Gothic" pitchFamily="34" charset="-122"/>
                 <a:cs typeface="Malgun Gothic" pitchFamily="34" charset="-120"/>
               </a:rPr>
-              <a:t>최소 권한: 파일시스템=읽기전용+특정 디렉토리, DB=SELECT 전용 계정, API=읽기 키 우선.</a:t>
-            </a:r>
-            <a:endParaRPr lang="en-US" sz="1550" dirty="0"/>
+              <a:t>API 키·비밀키는 코드에 직접 쓰지 않고 .env 파일에 분리한다.</a:t>
+            </a:r>
+            <a:endParaRPr lang="en-US" sz="1600" dirty="0"/>
           </a:p>
           <a:p>
             <a:pPr marL="203200" indent="-203200">
@@ -6015,13 +6065,13 @@
                 <a:spcPct val="105000"/>
               </a:lnSpc>
               <a:spcAft>
-                <a:spcPts val="1200"/>
+                <a:spcPts val="1500"/>
               </a:spcAft>
               <a:buSzPct val="100000"/>
               <a:buChar char="–"/>
             </a:pPr>
             <a:r>
-              <a:rPr lang="en-US" sz="1550" dirty="0">
+              <a:rPr lang="en-US" sz="1600" dirty="0">
                 <a:solidFill>
                   <a:srgbClr val="3E4C59"/>
                 </a:solidFill>
@@ -6029,9 +6079,9 @@
                 <a:ea typeface="Malgun Gothic" pitchFamily="34" charset="-122"/>
                 <a:cs typeface="Malgun Gothic" pitchFamily="34" charset="-120"/>
               </a:rPr>
-              <a:t>실행 명령 필터링: 허용 명령만 화이트리스트로 등록, 입력값 검증(SQL·쉘 인젝션 방지).</a:t>
-            </a:r>
-            <a:endParaRPr lang="en-US" sz="1550" dirty="0"/>
+              <a:t>.env는 .gitignore에 넣어 Git 등 버전 관리에 올라가지 않게 한다.</a:t>
+            </a:r>
+            <a:endParaRPr lang="en-US" sz="1600" dirty="0"/>
           </a:p>
           <a:p>
             <a:pPr marL="203200" indent="-203200">
@@ -6039,13 +6089,13 @@
                 <a:spcPct val="105000"/>
               </a:lnSpc>
               <a:spcAft>
-                <a:spcPts val="1200"/>
+                <a:spcPts val="1500"/>
               </a:spcAft>
               <a:buSzPct val="100000"/>
               <a:buChar char="–"/>
             </a:pPr>
             <a:r>
-              <a:rPr lang="en-US" sz="1550" dirty="0">
+              <a:rPr lang="en-US" sz="1600" dirty="0">
                 <a:solidFill>
                   <a:srgbClr val="3E4C59"/>
                 </a:solidFill>
@@ -6053,33 +6103,48 @@
                 <a:ea typeface="Malgun Gothic" pitchFamily="34" charset="-122"/>
                 <a:cs typeface="Malgun Gothic" pitchFamily="34" charset="-120"/>
               </a:rPr>
-              <a:t>접근 제어: 사용자 유형별 기능 제한, JWT·OAuth2·세션 인증.</a:t>
-            </a:r>
-            <a:endParaRPr lang="en-US" sz="1550" dirty="0"/>
-          </a:p>
-          <a:p>
-            <a:pPr marL="203200" indent="-203200">
-              <a:lnSpc>
-                <a:spcPct val="105000"/>
-              </a:lnSpc>
-              <a:spcAft>
-                <a:spcPts val="1200"/>
-              </a:spcAft>
-              <a:buSzPct val="100000"/>
-              <a:buChar char="–"/>
+              <a:t>환경 변수 로딩 실패 시 안전한 기본값 제공 또는 예외 처리로 서비스 중단을 막는다.</a:t>
+            </a:r>
+            <a:endParaRPr lang="en-US" sz="1600" dirty="0"/>
+          </a:p>
+        </p:txBody>
+      </p:sp>
+      <p:sp>
+        <p:nvSpPr>
+          <p:cNvPr id="5" name="Text 3"/>
+          <p:cNvSpPr/>
+          <p:nvPr/>
+        </p:nvSpPr>
+        <p:spPr>
+          <a:xfrm>
+            <a:off x="822960" y="4572000"/>
+            <a:ext cx="10698480" cy="457200"/>
+          </a:xfrm>
+          <a:prstGeom prst="rect">
+            <a:avLst/>
+          </a:prstGeom>
+          <a:noFill/>
+          <a:ln/>
+        </p:spPr>
+        <p:txBody>
+          <a:bodyPr wrap="square" lIns="0" tIns="0" rIns="0" bIns="0" rtlCol="0" anchor="ctr"/>
+          <a:lstStyle/>
+          <a:p>
+            <a:pPr indent="0" marL="0">
+              <a:buNone/>
             </a:pPr>
             <a:r>
-              <a:rPr lang="en-US" sz="1550" dirty="0">
+              <a:rPr lang="en-US" sz="1500" b="1" dirty="0">
                 <a:solidFill>
-                  <a:srgbClr val="3E4C59"/>
+                  <a:srgbClr val="0B7285"/>
                 </a:solidFill>
                 <a:latin typeface="Malgun Gothic" pitchFamily="34" charset="0"/>
                 <a:ea typeface="Malgun Gothic" pitchFamily="34" charset="-122"/>
                 <a:cs typeface="Malgun Gothic" pitchFamily="34" charset="-120"/>
               </a:rPr>
-              <a:t>인증 실패 처리: 일반화된 오류 메시지, 반복 실패 시 잠금·차단, 모든 실패 로그 기록.</a:t>
-            </a:r>
-            <a:endParaRPr lang="en-US" sz="1550" dirty="0"/>
+              <a:t>★ 우리 실습에서도 cli_project의 .env를 .gitignore로 제외했다.</a:t>
+            </a:r>
+            <a:endParaRPr lang="en-US" sz="1500" dirty="0"/>
           </a:p>
         </p:txBody>
       </p:sp>
@@ -6097,7 +6162,7 @@
     <p:bg>
       <p:bgPr>
         <a:solidFill>
-          <a:srgbClr val="F5F7FA"/>
+          <a:srgbClr val="FFFFFF"/>
         </a:solidFill>
       </p:bgPr>
     </p:bg>
@@ -6148,7 +6213,7 @@
                 <a:ea typeface="Malgun Gothic" pitchFamily="34" charset="-122"/>
                 <a:cs typeface="Malgun Gothic" pitchFamily="34" charset="-120"/>
               </a:rPr>
-              <a:t>정리</a:t>
+              <a:t>권한 관리 (AUTHORIZATION)</a:t>
             </a:r>
             <a:endParaRPr lang="en-US" sz="1200" dirty="0"/>
           </a:p>
@@ -6187,7 +6252,7 @@
                 <a:ea typeface="Malgun Gothic" pitchFamily="34" charset="-122"/>
                 <a:cs typeface="Malgun Gothic" pitchFamily="34" charset="-120"/>
               </a:rPr>
-              <a:t>한 장 요약</a:t>
+              <a:t>최소 권한 원칙</a:t>
             </a:r>
             <a:endParaRPr lang="en-US" sz="2800" dirty="0"/>
           </a:p>
@@ -6201,7 +6266,7 @@
         </p:nvSpPr>
         <p:spPr>
           <a:xfrm>
-            <a:off x="822960" y="1828800"/>
+            <a:off x="822960" y="1920240"/>
             <a:ext cx="10698480" cy="3200400"/>
           </a:xfrm>
           <a:prstGeom prst="rect">
@@ -6225,7 +6290,7 @@
               <a:buChar char="–"/>
             </a:pPr>
             <a:r>
-              <a:rPr lang="en-US" sz="1600" dirty="0">
+              <a:rPr lang="en-US" sz="1550" dirty="0">
                 <a:solidFill>
                   <a:srgbClr val="3E4C59"/>
                 </a:solidFill>
@@ -6233,9 +6298,9 @@
                 <a:ea typeface="Malgun Gothic" pitchFamily="34" charset="-122"/>
                 <a:cs typeface="Malgun Gothic" pitchFamily="34" charset="-120"/>
               </a:rPr>
-              <a:t>MCP = AI를 외부 도구·데이터에 잇는 개방형 표준 ("AI의 USB-C").</a:t>
-            </a:r>
-            <a:endParaRPr lang="en-US" sz="1600" dirty="0"/>
+              <a:t>최소 권한: 파일시스템=읽기전용+특정 디렉토리, DB=SELECT 전용 계정, API=읽기 키 우선.</a:t>
+            </a:r>
+            <a:endParaRPr lang="en-US" sz="1550" dirty="0"/>
           </a:p>
           <a:p>
             <a:pPr marL="203200" indent="-203200">
@@ -6249,7 +6314,7 @@
               <a:buChar char="–"/>
             </a:pPr>
             <a:r>
-              <a:rPr lang="en-US" sz="1600" dirty="0">
+              <a:rPr lang="en-US" sz="1550" dirty="0">
                 <a:solidFill>
                   <a:srgbClr val="3E4C59"/>
                 </a:solidFill>
@@ -6257,9 +6322,9 @@
                 <a:ea typeface="Malgun Gothic" pitchFamily="34" charset="-122"/>
                 <a:cs typeface="Malgun Gothic" pitchFamily="34" charset="-120"/>
               </a:rPr>
-              <a:t>3요소: Host(지휘관) · Client(중개자) · Server(도구 제공).</a:t>
-            </a:r>
-            <a:endParaRPr lang="en-US" sz="1600" dirty="0"/>
+              <a:t>실행 명령 필터링: 허용 명령만 화이트리스트로 등록, 입력값 검증(SQL·쉘 인젝션 방지).</a:t>
+            </a:r>
+            <a:endParaRPr lang="en-US" sz="1550" dirty="0"/>
           </a:p>
           <a:p>
             <a:pPr marL="203200" indent="-203200">
@@ -6273,7 +6338,7 @@
               <a:buChar char="–"/>
             </a:pPr>
             <a:r>
-              <a:rPr lang="en-US" sz="1600" dirty="0">
+              <a:rPr lang="en-US" sz="1550" dirty="0">
                 <a:solidFill>
                   <a:srgbClr val="3E4C59"/>
                 </a:solidFill>
@@ -6281,9 +6346,9 @@
                 <a:ea typeface="Malgun Gothic" pitchFamily="34" charset="-122"/>
                 <a:cs typeface="Malgun Gothic" pitchFamily="34" charset="-120"/>
               </a:rPr>
-              <a:t>전송 방식: stdio(로컬) · Streamable HTTP(원격).</a:t>
-            </a:r>
-            <a:endParaRPr lang="en-US" sz="1600" dirty="0"/>
+              <a:t>접근 제어: 사용자 유형별 기능 제한, JWT·OAuth2·세션 인증.</a:t>
+            </a:r>
+            <a:endParaRPr lang="en-US" sz="1550" dirty="0"/>
           </a:p>
           <a:p>
             <a:pPr marL="203200" indent="-203200">
@@ -6297,7 +6362,7 @@
               <a:buChar char="–"/>
             </a:pPr>
             <a:r>
-              <a:rPr lang="en-US" sz="1600" dirty="0">
+              <a:rPr lang="en-US" sz="1550" dirty="0">
                 <a:solidFill>
                   <a:srgbClr val="3E4C59"/>
                 </a:solidFill>
@@ -6305,33 +6370,9 @@
                 <a:ea typeface="Malgun Gothic" pitchFamily="34" charset="-122"/>
                 <a:cs typeface="Malgun Gothic" pitchFamily="34" charset="-120"/>
               </a:rPr>
-              <a:t>서버 기능: Tools · Resources · Prompts.</a:t>
-            </a:r>
-            <a:endParaRPr lang="en-US" sz="1600" dirty="0"/>
-          </a:p>
-          <a:p>
-            <a:pPr marL="203200" indent="-203200">
-              <a:lnSpc>
-                <a:spcPct val="105000"/>
-              </a:lnSpc>
-              <a:spcAft>
-                <a:spcPts val="1200"/>
-              </a:spcAft>
-              <a:buSzPct val="100000"/>
-              <a:buChar char="–"/>
-            </a:pPr>
-            <a:r>
-              <a:rPr lang="en-US" sz="1600" dirty="0">
-                <a:solidFill>
-                  <a:srgbClr val="3E4C59"/>
-                </a:solidFill>
-                <a:latin typeface="Malgun Gothic" pitchFamily="34" charset="0"/>
-                <a:ea typeface="Malgun Gothic" pitchFamily="34" charset="-122"/>
-                <a:cs typeface="Malgun Gothic" pitchFamily="34" charset="-120"/>
-              </a:rPr>
-              <a:t>만능은 아님 — 요청/응답에 맞는 영역에서 강력하며, 키·권한 등 보안이 필수.</a:t>
-            </a:r>
-            <a:endParaRPr lang="en-US" sz="1600" dirty="0"/>
+              <a:t>인증 실패 처리: 일반화된 오류 메시지, 반복 실패 시 잠금·차단, 모든 실패 로그 기록.</a:t>
+            </a:r>
+            <a:endParaRPr lang="en-US" sz="1550" dirty="0"/>
           </a:p>
         </p:txBody>
       </p:sp>
@@ -6575,6 +6616,258 @@
               <a:t>→ 이 연결을 표준화한 것이 MCP.</a:t>
             </a:r>
             <a:endParaRPr lang="en-US" sz="1700" dirty="0"/>
+          </a:p>
+        </p:txBody>
+      </p:sp>
+    </p:spTree>
+  </p:cSld>
+  <p:clrMapOvr>
+    <a:masterClrMapping/>
+  </p:clrMapOvr>
+</p:sld>
+</file>
+
+<file path=ppt/slides/slide20.xml><?xml version="1.0" encoding="utf-8"?>
+<p:sld xmlns:a="http://schemas.openxmlformats.org/drawingml/2006/main" xmlns:r="http://schemas.openxmlformats.org/officeDocument/2006/relationships" xmlns:p="http://schemas.openxmlformats.org/presentationml/2006/main">
+  <p:cSld name="Slide 20">
+    <p:bg>
+      <p:bgPr>
+        <a:solidFill>
+          <a:srgbClr val="F5F7FA"/>
+        </a:solidFill>
+      </p:bgPr>
+    </p:bg>
+    <p:spTree>
+      <p:nvGrpSpPr>
+        <p:cNvPr id="1" name=""/>
+        <p:cNvGrpSpPr/>
+        <p:nvPr/>
+      </p:nvGrpSpPr>
+      <p:grpSpPr>
+        <a:xfrm>
+          <a:off x="0" y="0"/>
+          <a:ext cx="0" cy="0"/>
+          <a:chOff x="0" y="0"/>
+          <a:chExt cx="0" cy="0"/>
+        </a:xfrm>
+      </p:grpSpPr>
+      <p:sp>
+        <p:nvSpPr>
+          <p:cNvPr id="2" name="Text 0"/>
+          <p:cNvSpPr/>
+          <p:nvPr/>
+        </p:nvSpPr>
+        <p:spPr>
+          <a:xfrm>
+            <a:off x="640080" y="502920"/>
+            <a:ext cx="10972800" cy="320040"/>
+          </a:xfrm>
+          <a:prstGeom prst="rect">
+            <a:avLst/>
+          </a:prstGeom>
+          <a:noFill/>
+          <a:ln/>
+        </p:spPr>
+        <p:txBody>
+          <a:bodyPr wrap="square" lIns="0" tIns="0" rIns="0" bIns="0" rtlCol="0" anchor="ctr"/>
+          <a:lstStyle/>
+          <a:p>
+            <a:pPr indent="0" marL="0">
+              <a:buNone/>
+            </a:pPr>
+            <a:r>
+              <a:rPr lang="en-US" sz="1200" b="1" spc="200" kern="0" dirty="0">
+                <a:solidFill>
+                  <a:srgbClr val="0B7285"/>
+                </a:solidFill>
+                <a:latin typeface="Malgun Gothic" pitchFamily="34" charset="0"/>
+                <a:ea typeface="Malgun Gothic" pitchFamily="34" charset="-122"/>
+                <a:cs typeface="Malgun Gothic" pitchFamily="34" charset="-120"/>
+              </a:rPr>
+              <a:t>정리</a:t>
+            </a:r>
+            <a:endParaRPr lang="en-US" sz="1200" dirty="0"/>
+          </a:p>
+        </p:txBody>
+      </p:sp>
+      <p:sp>
+        <p:nvSpPr>
+          <p:cNvPr id="3" name="Text 1"/>
+          <p:cNvSpPr/>
+          <p:nvPr/>
+        </p:nvSpPr>
+        <p:spPr>
+          <a:xfrm>
+            <a:off x="640080" y="841248"/>
+            <a:ext cx="10972800" cy="640080"/>
+          </a:xfrm>
+          <a:prstGeom prst="rect">
+            <a:avLst/>
+          </a:prstGeom>
+          <a:noFill/>
+          <a:ln/>
+        </p:spPr>
+        <p:txBody>
+          <a:bodyPr wrap="square" lIns="0" tIns="0" rIns="0" bIns="0" rtlCol="0" anchor="ctr"/>
+          <a:lstStyle/>
+          <a:p>
+            <a:pPr indent="0" marL="0">
+              <a:buNone/>
+            </a:pPr>
+            <a:r>
+              <a:rPr lang="en-US" sz="2800" b="1" dirty="0">
+                <a:solidFill>
+                  <a:srgbClr val="1F2933"/>
+                </a:solidFill>
+                <a:latin typeface="Malgun Gothic" pitchFamily="34" charset="0"/>
+                <a:ea typeface="Malgun Gothic" pitchFamily="34" charset="-122"/>
+                <a:cs typeface="Malgun Gothic" pitchFamily="34" charset="-120"/>
+              </a:rPr>
+              <a:t>한 장 요약</a:t>
+            </a:r>
+            <a:endParaRPr lang="en-US" sz="2800" dirty="0"/>
+          </a:p>
+        </p:txBody>
+      </p:sp>
+      <p:sp>
+        <p:nvSpPr>
+          <p:cNvPr id="4" name="Text 2"/>
+          <p:cNvSpPr/>
+          <p:nvPr/>
+        </p:nvSpPr>
+        <p:spPr>
+          <a:xfrm>
+            <a:off x="822960" y="1828800"/>
+            <a:ext cx="10698480" cy="3200400"/>
+          </a:xfrm>
+          <a:prstGeom prst="rect">
+            <a:avLst/>
+          </a:prstGeom>
+          <a:noFill/>
+          <a:ln/>
+        </p:spPr>
+        <p:txBody>
+          <a:bodyPr wrap="square" lIns="0" tIns="0" rIns="0" bIns="0" rtlCol="0" anchor="ctr"/>
+          <a:lstStyle/>
+          <a:p>
+            <a:pPr marL="203200" indent="-203200">
+              <a:lnSpc>
+                <a:spcPct val="105000"/>
+              </a:lnSpc>
+              <a:spcAft>
+                <a:spcPts val="1200"/>
+              </a:spcAft>
+              <a:buSzPct val="100000"/>
+              <a:buChar char="–"/>
+            </a:pPr>
+            <a:r>
+              <a:rPr lang="en-US" sz="1600" dirty="0">
+                <a:solidFill>
+                  <a:srgbClr val="3E4C59"/>
+                </a:solidFill>
+                <a:latin typeface="Malgun Gothic" pitchFamily="34" charset="0"/>
+                <a:ea typeface="Malgun Gothic" pitchFamily="34" charset="-122"/>
+                <a:cs typeface="Malgun Gothic" pitchFamily="34" charset="-120"/>
+              </a:rPr>
+              <a:t>MCP = AI를 외부 도구·데이터에 잇는 개방형 표준 ("AI의 USB-C").</a:t>
+            </a:r>
+            <a:endParaRPr lang="en-US" sz="1600" dirty="0"/>
+          </a:p>
+          <a:p>
+            <a:pPr marL="203200" indent="-203200">
+              <a:lnSpc>
+                <a:spcPct val="105000"/>
+              </a:lnSpc>
+              <a:spcAft>
+                <a:spcPts val="1200"/>
+              </a:spcAft>
+              <a:buSzPct val="100000"/>
+              <a:buChar char="–"/>
+            </a:pPr>
+            <a:r>
+              <a:rPr lang="en-US" sz="1600" dirty="0">
+                <a:solidFill>
+                  <a:srgbClr val="3E4C59"/>
+                </a:solidFill>
+                <a:latin typeface="Malgun Gothic" pitchFamily="34" charset="0"/>
+                <a:ea typeface="Malgun Gothic" pitchFamily="34" charset="-122"/>
+                <a:cs typeface="Malgun Gothic" pitchFamily="34" charset="-120"/>
+              </a:rPr>
+              <a:t>3요소: Host(지휘관) · Client(중개자) · Server(도구 제공).</a:t>
+            </a:r>
+            <a:endParaRPr lang="en-US" sz="1600" dirty="0"/>
+          </a:p>
+          <a:p>
+            <a:pPr marL="203200" indent="-203200">
+              <a:lnSpc>
+                <a:spcPct val="105000"/>
+              </a:lnSpc>
+              <a:spcAft>
+                <a:spcPts val="1200"/>
+              </a:spcAft>
+              <a:buSzPct val="100000"/>
+              <a:buChar char="–"/>
+            </a:pPr>
+            <a:r>
+              <a:rPr lang="en-US" sz="1600" dirty="0">
+                <a:solidFill>
+                  <a:srgbClr val="3E4C59"/>
+                </a:solidFill>
+                <a:latin typeface="Malgun Gothic" pitchFamily="34" charset="0"/>
+                <a:ea typeface="Malgun Gothic" pitchFamily="34" charset="-122"/>
+                <a:cs typeface="Malgun Gothic" pitchFamily="34" charset="-120"/>
+              </a:rPr>
+              <a:t>전송 방식: stdio(로컬) · Streamable HTTP(원격).</a:t>
+            </a:r>
+            <a:endParaRPr lang="en-US" sz="1600" dirty="0"/>
+          </a:p>
+          <a:p>
+            <a:pPr marL="203200" indent="-203200">
+              <a:lnSpc>
+                <a:spcPct val="105000"/>
+              </a:lnSpc>
+              <a:spcAft>
+                <a:spcPts val="1200"/>
+              </a:spcAft>
+              <a:buSzPct val="100000"/>
+              <a:buChar char="–"/>
+            </a:pPr>
+            <a:r>
+              <a:rPr lang="en-US" sz="1600" dirty="0">
+                <a:solidFill>
+                  <a:srgbClr val="3E4C59"/>
+                </a:solidFill>
+                <a:latin typeface="Malgun Gothic" pitchFamily="34" charset="0"/>
+                <a:ea typeface="Malgun Gothic" pitchFamily="34" charset="-122"/>
+                <a:cs typeface="Malgun Gothic" pitchFamily="34" charset="-120"/>
+              </a:rPr>
+              <a:t>서버 기능: Tools · Resources · Prompts.</a:t>
+            </a:r>
+            <a:endParaRPr lang="en-US" sz="1600" dirty="0"/>
+          </a:p>
+          <a:p>
+            <a:pPr marL="203200" indent="-203200">
+              <a:lnSpc>
+                <a:spcPct val="105000"/>
+              </a:lnSpc>
+              <a:spcAft>
+                <a:spcPts val="1200"/>
+              </a:spcAft>
+              <a:buSzPct val="100000"/>
+              <a:buChar char="–"/>
+            </a:pPr>
+            <a:r>
+              <a:rPr lang="en-US" sz="1600" dirty="0">
+                <a:solidFill>
+                  <a:srgbClr val="3E4C59"/>
+                </a:solidFill>
+                <a:latin typeface="Malgun Gothic" pitchFamily="34" charset="0"/>
+                <a:ea typeface="Malgun Gothic" pitchFamily="34" charset="-122"/>
+                <a:cs typeface="Malgun Gothic" pitchFamily="34" charset="-120"/>
+              </a:rPr>
+              <a:t>만능은 아님 — 요청/응답에 맞는 영역에서 강력하며, 키·권한 등 보안이 필수.</a:t>
+            </a:r>
+            <a:endParaRPr lang="en-US" sz="1600" dirty="0"/>
           </a:p>
         </p:txBody>
       </p:sp>
@@ -9349,7 +9642,7 @@
                 <a:ea typeface="Malgun Gothic" pitchFamily="34" charset="-122"/>
                 <a:cs typeface="Malgun Gothic" pitchFamily="34" charset="-120"/>
               </a:rPr>
-              <a:t>① MCP HOST</a:t>
+              <a:t>PART 2 · 아키텍처</a:t>
             </a:r>
             <a:endParaRPr lang="en-US" sz="1200" dirty="0"/>
           </a:p>
@@ -9388,22 +9681,46 @@
                 <a:ea typeface="Malgun Gothic" pitchFamily="34" charset="-122"/>
                 <a:cs typeface="Malgun Gothic" pitchFamily="34" charset="-120"/>
               </a:rPr>
-              <a:t>MCP Host — 지휘관</a:t>
+              <a:t>MCP 아키텍처 — 공식 다이어그램</a:t>
             </a:r>
             <a:endParaRPr lang="en-US" sz="2800" dirty="0"/>
           </a:p>
         </p:txBody>
       </p:sp>
-      <p:sp>
-        <p:nvSpPr>
-          <p:cNvPr id="4" name="Text 2"/>
+      <p:pic>
+        <p:nvPicPr>
+          <p:cNvPr id="4" name="Image 0" descr="MCP/mcp-architecture.png">    </p:cNvPr>
+          <p:cNvPicPr>
+            <a:picLocks noChangeAspect="1"/>
+          </p:cNvPicPr>
+          <p:nvPr/>
+        </p:nvPicPr>
+        <p:blipFill>
+          <a:blip r:embed="rId1"/>
+          <a:stretch>
+            <a:fillRect/>
+          </a:stretch>
+        </p:blipFill>
+        <p:spPr>
+          <a:xfrm>
+            <a:off x="2212848" y="1783080"/>
+            <a:ext cx="7772400" cy="4379976"/>
+          </a:xfrm>
+          <a:prstGeom prst="rect">
+            <a:avLst/>
+          </a:prstGeom>
+        </p:spPr>
+      </p:pic>
+      <p:sp>
+        <p:nvSpPr>
+          <p:cNvPr id="5" name="Text 2"/>
           <p:cNvSpPr/>
           <p:nvPr/>
         </p:nvSpPr>
         <p:spPr>
           <a:xfrm>
-            <a:off x="822960" y="1920240"/>
-            <a:ext cx="10698480" cy="3200400"/>
+            <a:off x="640080" y="6263640"/>
+            <a:ext cx="10972800" cy="457200"/>
           </a:xfrm>
           <a:prstGeom prst="rect">
             <a:avLst/>
@@ -9415,76 +9732,21 @@
           <a:bodyPr wrap="square" lIns="0" tIns="0" rIns="0" bIns="0" rtlCol="0" anchor="ctr"/>
           <a:lstStyle/>
           <a:p>
-            <a:pPr marL="203200" indent="-203200">
-              <a:lnSpc>
-                <a:spcPct val="105000"/>
-              </a:lnSpc>
-              <a:spcAft>
-                <a:spcPts val="1600"/>
-              </a:spcAft>
-              <a:buSzPct val="100000"/>
-              <a:buChar char="–"/>
+            <a:pPr algn="ctr" indent="0" marL="0">
+              <a:buNone/>
             </a:pPr>
             <a:r>
-              <a:rPr lang="en-US" sz="1600" dirty="0">
+              <a:rPr lang="en-US" sz="1400" i="1" dirty="0">
                 <a:solidFill>
-                  <a:srgbClr val="3E4C59"/>
+                  <a:srgbClr val="7B8794"/>
                 </a:solidFill>
                 <a:latin typeface="Malgun Gothic" pitchFamily="34" charset="0"/>
                 <a:ea typeface="Malgun Gothic" pitchFamily="34" charset="-122"/>
                 <a:cs typeface="Malgun Gothic" pitchFamily="34" charset="-120"/>
               </a:rPr>
-              <a:t>모든 것을 결정하는 앱 본체. LLM을 품고 있다.</a:t>
-            </a:r>
-            <a:endParaRPr lang="en-US" sz="1600" dirty="0"/>
-          </a:p>
-          <a:p>
-            <a:pPr marL="203200" indent="-203200">
-              <a:lnSpc>
-                <a:spcPct val="105000"/>
-              </a:lnSpc>
-              <a:spcAft>
-                <a:spcPts val="1600"/>
-              </a:spcAft>
-              <a:buSzPct val="100000"/>
-              <a:buChar char="–"/>
-            </a:pPr>
-            <a:r>
-              <a:rPr lang="en-US" sz="1600" dirty="0">
-                <a:solidFill>
-                  <a:srgbClr val="3E4C59"/>
-                </a:solidFill>
-                <a:latin typeface="Malgun Gothic" pitchFamily="34" charset="0"/>
-                <a:ea typeface="Malgun Gothic" pitchFamily="34" charset="-122"/>
-                <a:cs typeface="Malgun Gothic" pitchFamily="34" charset="-120"/>
-              </a:rPr>
-              <a:t>사용자 요청 이해·분석 → 필요한 도구 결정 → 작업 계획 수립 → 최종 응답 생성.</a:t>
-            </a:r>
-            <a:endParaRPr lang="en-US" sz="1600" dirty="0"/>
-          </a:p>
-          <a:p>
-            <a:pPr marL="203200" indent="-203200">
-              <a:lnSpc>
-                <a:spcPct val="105000"/>
-              </a:lnSpc>
-              <a:spcAft>
-                <a:spcPts val="1600"/>
-              </a:spcAft>
-              <a:buSzPct val="100000"/>
-              <a:buChar char="–"/>
-            </a:pPr>
-            <a:r>
-              <a:rPr lang="en-US" sz="1600" dirty="0">
-                <a:solidFill>
-                  <a:srgbClr val="3E4C59"/>
-                </a:solidFill>
-                <a:latin typeface="Malgun Gothic" pitchFamily="34" charset="0"/>
-                <a:ea typeface="Malgun Gothic" pitchFamily="34" charset="-122"/>
-                <a:cs typeface="Malgun Gothic" pitchFamily="34" charset="-120"/>
-              </a:rPr>
-              <a:t>예: Claude Desktop, Cursor.</a:t>
-            </a:r>
-            <a:endParaRPr lang="en-US" sz="1600" dirty="0"/>
+              <a:t>Host(Claude 등) 안의 Client가, USB-C 허브처럼 여러 MCP Server(Slack·Gmail·로컬 등)에 표준 하나로 연결된다.</a:t>
+            </a:r>
+            <a:endParaRPr lang="en-US" sz="1400" dirty="0"/>
           </a:p>
         </p:txBody>
       </p:sp>

</xml_diff>